<commit_message>
Use invented names in the sample data and every figure made from it
gen_sample.py copied each staff member's name, employee number, phone,
link id and hourly wage from the source CSV and only invented the
shifts, so the "sample" workbook, the guide figures and the slide
images all showed fabricated attendance under real people's names. The
generator now replaces those fields with invented values (keeping the
department prefix and qualification suffix of each name so grouping and
the promotion logic still work) and jitters the wage. Every figure in
docs/img, both guide PDFs and both PowerPoints are rebuilt from the new
sample; the shift content is unchanged so all numbers stay the same.

Co-Authored-By: Claude Fable 5.1 <noreply@anthropic.com>
Claude-Session: https://claude.ai/code/session_01CZAayVGkaBSKqnddqBHzhf
</commit_message>
<xml_diff>
--- a/tools/attendance_dashboard/docs/勤務実績ダッシュボード_運用ガイド.pptx
+++ b/tools/attendance_dashboard/docs/勤務実績ダッシュボード_運用ガイド.pptx
@@ -3795,7 +3795,7 @@
         <p:spPr>
           <a:xfrm>
             <a:off x="3405336" y="3463975"/>
-            <a:ext cx="3722638" cy="775543"/>
+            <a:ext cx="3722638" cy="589359"/>
           </a:xfrm>
           <a:prstGeom prst="rect">
             <a:avLst/>
@@ -3811,7 +3811,7 @@
         <p:spPr>
           <a:xfrm>
             <a:off x="3405336" y="3463975"/>
-            <a:ext cx="3722638" cy="775543"/>
+            <a:ext cx="3722638" cy="589359"/>
           </a:xfrm>
           <a:prstGeom prst="rect">
             <a:avLst/>
@@ -3833,7 +3833,7 @@
         </p:nvSpPr>
         <p:spPr>
           <a:xfrm>
-            <a:off x="3405336" y="4268242"/>
+            <a:off x="3405336" y="4082058"/>
             <a:ext cx="3722638" cy="131118"/>
           </a:xfrm>
           <a:prstGeom prst="rect">

</xml_diff>